<commit_message>
data(resultados): reestimação E2 e entregáveis regenerados (04/10/2026)
Números que mudaram com a especificação (A) ≡ M3 (jornada, urbano e UF):
- Oaxaca: retornos 23,4% → 17,9% (A) e 17,3% → 15,4% (B).
- RIF: retornos q10 32,3% → 26,5%, q90 9,1% → 8,9% (razão 3,5 → 3,0).
- QR M3: q10 5,7% → 4,3%, q90 8,7% → 8,4%; teste KB Z = −25,9.
- E-value do acesso 1,76 → 1,46 (√OR para desfecho comum).
Novos: gap_agregado.csv (sem UF 20,1%), hlm_m1_uf.csv (mediação com UF 41,6%),
grupo_rg_por_cbo.csv (mulher negra: dirigentes OR 0,63, administrativo 1,96),
glmm_prevalencias.csv.

Entregáveis regenerados às 11:47 com todos os portões OK (caca_fosseis 0,
conferir_numeros 0, validate consistente, conferência das normas OK);
TCC com 45 páginas e 41 referências.

Co-Authored-By: Claude Opus 5.5 (1M context) <noreply@anthropic.com>
Claude-Session: https://claude.ai/code/session_01ATPBca6o9jxRv5wGBtSSkf
</commit_message>
<xml_diff>
--- a/entregaveis/TCC_Ricardo_Calheiros_Executiva.pptx
+++ b/entregaveis/TCC_Ricardo_Calheiros_Executiva.pptx
@@ -3285,7 +3285,7 @@
                 </a:solidFill>
                 <a:latin typeface="Calibri"/>
               </a:rPr>
-              <a:t>PNAD Contínua 2016–2025 · 7,7 milhões de trabalhadores · 40.969 bairros</a:t>
+              <a:t>PNAD Contínua 2016–2025 · 7,7 milhões de trabalhadores · 41.454 bairros</a:t>
             </a:r>
           </a:p>
           <a:p>
@@ -3466,7 +3466,7 @@
                 </a:solidFill>
                 <a:latin typeface="Calibri"/>
               </a:rPr>
-              <a:t>Cada barreira medida tem um instrumento legal que já existe</a:t>
+              <a:t>Onde os instrumentos vigentes alcançam as barreiras, e onde não alcançam</a:t>
             </a:r>
           </a:p>
         </p:txBody>
@@ -3501,7 +3501,7 @@
                 </a:solidFill>
                 <a:latin typeface="Calibri"/>
               </a:rPr>
-              <a:t>O diagnóstico aponta onde intensificar, não o que inventar</a:t>
+              <a:t>O diagnóstico aponta o que intensificar e o que ainda falta</a:t>
             </a:r>
           </a:p>
         </p:txBody>
@@ -3613,7 +3613,7 @@
                 </a:solidFill>
                 <a:latin typeface="Calibri"/>
               </a:rPr>
-              <a:t>Lei 12.990/2014 (cotas em concursos federais)</a:t>
+              <a:t>Lei 15.142/2025 (30% das vagas em concursos federais)</a:t>
             </a:r>
           </a:p>
         </p:txBody>
@@ -3648,7 +3648,7 @@
                 </a:solidFill>
                 <a:latin typeface="Calibri"/>
               </a:rPr>
-              <a:t>O diagnóstico sugere ampliar o alcance para níveis hierárquicos superiores, onde a porta é mais estreita (−35% no topo 10%).</a:t>
+              <a:t>O diagnóstico sugere ampliar o alcance para níveis hierárquicos superiores, onde a porta é mais estreita (−24% no topo 10%).</a:t>
             </a:r>
           </a:p>
         </p:txBody>
@@ -3942,7 +3942,7 @@
                 </a:solidFill>
                 <a:latin typeface="Calibri"/>
               </a:rPr>
-              <a:t>O gap líquido de 10,2% — e os 7,0% que persistem dentro da mesma ocupação — justificam reforçar a fiscalização.</a:t>
+              <a:t>O gap líquido de 6,1% — e os 5,6% que persistem dentro da mesma ocupação — justificam reforçar a fiscalização.</a:t>
             </a:r>
           </a:p>
         </p:txBody>
@@ -3977,7 +3977,7 @@
                 </a:solidFill>
                 <a:latin typeface="Calibri"/>
               </a:rPr>
-              <a:t>Com a mesma escolaridade, idade, sexo e bairro, um trabalhador negro ganha 10,2% a menos — e a barreira mais dura não é o salário, é a porta.</a:t>
+              <a:t>Com a mesma escolaridade, idade, sexo e bairro, um trabalhador negro ganha 6,1% a menos e tem chances 19% menores de chegar a um cargo qualificado. O diploma quase iguala o salário, mas não abre a porta.</a:t>
             </a:r>
           </a:p>
         </p:txBody>
@@ -4142,7 +4142,7 @@
                 </a:solidFill>
                 <a:latin typeface="Calibri"/>
               </a:rPr>
-              <a:t>Educação explica o gap racial de renda? Os dados dizem que não</a:t>
+              <a:t>Educação explica o gap racial de renda? Só em parte</a:t>
             </a:r>
           </a:p>
         </p:txBody>
@@ -4577,7 +4577,7 @@
                 </a:solidFill>
                 <a:latin typeface="Calibri"/>
               </a:rPr>
-              <a:t>Dez anos de PNAD Contínua, sem amostragem</a:t>
+              <a:t>Dez anos de PNAD Contínua, com todos os registros</a:t>
             </a:r>
           </a:p>
         </p:txBody>
@@ -4612,7 +4612,7 @@
                 </a:solidFill>
                 <a:latin typeface="Calibri"/>
               </a:rPr>
-              <a:t>A base é a população de trabalhadores ocupados com rendimento, não uma amostra dela</a:t>
+              <a:t>Todos os trabalhadores ocupados com rendimento que a pesquisa entrevistou — nenhuma subamostra sorteada</a:t>
             </a:r>
           </a:p>
         </p:txBody>
@@ -4864,7 +4864,7 @@
                 </a:solidFill>
                 <a:latin typeface="Calibri"/>
               </a:rPr>
-              <a:t>Bairros (setores censitários)</a:t>
+              <a:t>Bairros (UPAs da PNAD)</a:t>
             </a:r>
           </a:p>
         </p:txBody>
@@ -4899,7 +4899,7 @@
                 </a:solidFill>
                 <a:latin typeface="Calibri"/>
               </a:rPr>
-              <a:t>40.969</a:t>
+              <a:t>41.454</a:t>
             </a:r>
           </a:p>
         </p:txBody>
@@ -5164,7 +5164,7 @@
                 </a:solidFill>
                 <a:latin typeface="Calibri"/>
               </a:rPr>
-              <a:t>Por que isso importa: com a população inteira, o resultado não depende de qual amostra foi sorteada. A pergunta deixa de ser “será que é ruído?” e passa a ser “qual é o tamanho do efeito?”.</a:t>
+              <a:t>Por que isso importa: com todos os registros, o resultado não depende de uma subamostra escolhida pelo autor. Com milhões de observações, a pergunta deixa de ser “será que é ruído?” e passa a ser “qual é o tamanho do efeito?”.</a:t>
             </a:r>
           </a:p>
           <a:p>
@@ -5345,7 +5345,7 @@
                 </a:solidFill>
                 <a:latin typeface="Calibri"/>
               </a:rPr>
-              <a:t>A primeira barreira é a porta: 30% menos chance de chegar a um cargo qualificado</a:t>
+              <a:t>Barreira de acesso: chances 19% menores de chegar a um cargo qualificado</a:t>
             </a:r>
           </a:p>
         </p:txBody>
@@ -5496,7 +5496,7 @@
                 </a:solidFill>
                 <a:latin typeface="Calibri"/>
               </a:rPr>
-              <a:t>−30%</a:t>
+              <a:t>−19%</a:t>
             </a:r>
           </a:p>
         </p:txBody>
@@ -5535,7 +5535,7 @@
                 </a:solidFill>
                 <a:latin typeface="Calibri"/>
               </a:rPr>
-              <a:t>chance (odds ratio 0,699)</a:t>
+              <a:t>chance (odds ratio 0,814)</a:t>
             </a:r>
           </a:p>
           <a:p>
@@ -5551,7 +5551,7 @@
                 </a:solidFill>
                 <a:latin typeface="Calibri"/>
               </a:rPr>
-              <a:t>= 5,5 pontos percentuais</a:t>
+              <a:t>= 2,6 pontos percentuais</a:t>
             </a:r>
           </a:p>
         </p:txBody>
@@ -5663,11 +5663,11 @@
             <a:r>
               <a:rPr sz="4000" b="1" i="0">
                 <a:solidFill>
-                  <a:srgbClr val="1565C0"/>
-                </a:solidFill>
-                <a:latin typeface="Calibri"/>
-              </a:rPr>
-              <a:t>−31%</a:t>
+                  <a:srgbClr val="B71C1C"/>
+                </a:solidFill>
+                <a:latin typeface="Calibri"/>
+              </a:rPr>
+              <a:t>−23%</a:t>
             </a:r>
           </a:p>
         </p:txBody>
@@ -5838,7 +5838,7 @@
                 </a:solidFill>
                 <a:latin typeface="Calibri"/>
               </a:rPr>
-              <a:t>−35%</a:t>
+              <a:t>−24%</a:t>
             </a:r>
           </a:p>
         </p:txBody>
@@ -5932,7 +5932,7 @@
                 </a:solidFill>
                 <a:latin typeface="Calibri"/>
               </a:rPr>
-              <a:t>Mesma escolaridade. Mesma idade. Mesmo sexo. Mesmo bairro. A diferença que resta é o acesso à ocupação — e ela é maior do que a diferença de salário.</a:t>
+              <a:t>Mesma escolaridade. Mesma idade. Mesmo sexo. Mesmo bairro. A diferença que resta é o acesso à ocupação — uma barreira que o salário sozinho não mostra.</a:t>
             </a:r>
           </a:p>
           <a:p>
@@ -5948,7 +5948,7 @@
                 </a:solidFill>
                 <a:latin typeface="Calibri"/>
               </a:rPr>
-              <a:t>Seria preciso um fator não medido associado tanto à raça quanto ao acesso com força de 2,2× para explicar esse resultado por inteiro — mais forte que ter ensino superior.</a:t>
+              <a:t>Para explicar esse resultado por inteiro, um fator não medido teria de se associar à raça e ao acesso com força de 1,5× — não é impossível, e por isso o resultado se apoia também em comparar pessoas do mesmo bairro.</a:t>
             </a:r>
           </a:p>
         </p:txBody>
@@ -6025,7 +6025,7 @@
                 </a:solidFill>
                 <a:latin typeface="Calibri"/>
               </a:rPr>
-              <a:t>A exclusão começa antes do contracheque.</a:t>
+              <a:t>A exclusão não começa só no contracheque: começa também na porta.</a:t>
             </a:r>
           </a:p>
         </p:txBody>
@@ -6190,7 +6190,7 @@
                 </a:solidFill>
                 <a:latin typeface="Calibri"/>
               </a:rPr>
-              <a:t>Metade do gap salarial desaparece ao comparar pessoas do mesmo bairro</a:t>
+              <a:t>Comparar vizinhos reduz o gap em cerca de 40%</a:t>
             </a:r>
           </a:p>
         </p:txBody>
@@ -6246,8 +6246,8 @@
         </p:blipFill>
         <p:spPr>
           <a:xfrm>
-            <a:off x="502920" y="1234440"/>
-            <a:ext cx="6858000" cy="3332272"/>
+            <a:off x="365760" y="1371600"/>
+            <a:ext cx="7406640" cy="3598854"/>
           </a:xfrm>
           <a:prstGeom prst="rect">
             <a:avLst/>
@@ -6262,8 +6262,8 @@
         </p:nvSpPr>
         <p:spPr>
           <a:xfrm>
-            <a:off x="7589520" y="1463040"/>
-            <a:ext cx="4206240" cy="3840480"/>
+            <a:off x="7955279" y="1463040"/>
+            <a:ext cx="3931920" cy="3840480"/>
           </a:xfrm>
           <a:prstGeom prst="rect">
             <a:avLst/>
@@ -6297,7 +6297,7 @@
                 </a:solidFill>
                 <a:latin typeface="Calibri"/>
               </a:rPr>
-              <a:t>Gap de partida: 19,1% a menos, mesma escolaridade e idade.</a:t>
+              <a:t>Gap de partida: 10,5% a menos, mesma escolaridade e idade.</a:t>
             </a:r>
           </a:p>
           <a:p>
@@ -6322,7 +6322,7 @@
                 </a:solidFill>
                 <a:latin typeface="Calibri"/>
               </a:rPr>
-              <a:t>47,0% desse gap é mediado pelo bairro de moradia.</a:t>
+              <a:t>39,5% desse gap é mediado pelo bairro de moradia.</a:t>
             </a:r>
           </a:p>
           <a:p>
@@ -6347,7 +6347,7 @@
                 </a:solidFill>
                 <a:latin typeface="Calibri"/>
               </a:rPr>
-              <a:t>Gap líquido: 10,2% — mesma escolaridade, idade, sexo e bairro.</a:t>
+              <a:t>Gap líquido: 6,1% — mesma escolaridade, idade, sexo e bairro.</a:t>
             </a:r>
           </a:p>
           <a:p>
@@ -6372,7 +6372,7 @@
                 </a:solidFill>
                 <a:latin typeface="Calibri"/>
               </a:rPr>
-              <a:t>Dentro da mesma ocupação ainda restam 7,0%.</a:t>
+              <a:t>Dentro da mesma ocupação ainda restam 5,6%.</a:t>
             </a:r>
           </a:p>
           <a:p>
@@ -6397,7 +6397,7 @@
                 </a:solidFill>
                 <a:latin typeface="Calibri"/>
               </a:rPr>
-              <a:t>37% da variação de renda está entre bairros, não entre pessoas.</a:t>
+              <a:t>35% da variação de renda está entre bairros, não entre pessoas.</a:t>
             </a:r>
           </a:p>
         </p:txBody>
@@ -6474,7 +6474,7 @@
                 </a:solidFill>
                 <a:latin typeface="Calibri"/>
               </a:rPr>
-              <a:t>Onde a pessoa mora explica metade do gap — política de renda que ignora território tem eficácia limitada.</a:t>
+              <a:t>Onde a pessoa mora responde por 39,5% do gap — política de renda que ignora território tem eficácia limitada.</a:t>
             </a:r>
           </a:p>
         </p:txBody>
@@ -6639,7 +6639,7 @@
                 </a:solidFill>
                 <a:latin typeface="Calibri"/>
               </a:rPr>
-              <a:t>28,4% do gap não é diferença de características: é preço diferente pelas mesmas características</a:t>
+              <a:t>17,9% do gap é preço diferente pelas mesmas características</a:t>
             </a:r>
           </a:p>
         </p:txBody>
@@ -6753,7 +6753,7 @@
                 </a:solidFill>
                 <a:latin typeface="Calibri"/>
               </a:rPr>
-              <a:t>• 71,6% do gap vem de os grupos terem características diferentes (dotações).</a:t>
+              <a:t>• 82,1% do gap vem de os grupos terem características diferentes (dotações).</a:t>
             </a:r>
           </a:p>
           <a:p>
@@ -6769,7 +6769,7 @@
                 </a:solidFill>
                 <a:latin typeface="Calibri"/>
               </a:rPr>
-              <a:t>• 28,4% vem de as mesmas características renderem menos a trabalhadores negros.</a:t>
+              <a:t>• 17,9% vem de as mesmas características renderem menos a trabalhadores negros.</a:t>
             </a:r>
           </a:p>
           <a:p>
@@ -6801,7 +6801,7 @@
                 </a:solidFill>
                 <a:latin typeface="Calibri"/>
               </a:rPr>
-              <a:t>Quando a ocupação entra como se fosse característica, essa segunda parcela cai para 16,2% — mas isso subestima o problema, porque o acesso à ocupação é ele próprio desigual (slide anterior).</a:t>
+              <a:t>Quando a ocupação entra como se fosse característica, essa segunda parcela cai para 15,4% — mas isso subestima o problema, porque o acesso à ocupação é ele próprio desigual — é a porta de entrada que o GLMM mede.</a:t>
             </a:r>
           </a:p>
         </p:txBody>
@@ -7043,7 +7043,7 @@
                 </a:solidFill>
                 <a:latin typeface="Calibri"/>
               </a:rPr>
-              <a:t>Quanto mais alto o salário, maior a penalidade racial</a:t>
+              <a:t>Entre pares, a penalidade racial cresce rumo ao topo</a:t>
             </a:r>
           </a:p>
         </p:txBody>
@@ -7078,7 +7078,7 @@
                 </a:solidFill>
                 <a:latin typeface="Calibri"/>
               </a:rPr>
-              <a:t>E, na base da distribuição, a maior parte do gap é preço, não característica</a:t>
+              <a:t>E, na base da distribuição, o preço pesa 3,0 vezes mais que no topo</a:t>
             </a:r>
           </a:p>
         </p:txBody>
@@ -7099,8 +7099,8 @@
         </p:blipFill>
         <p:spPr>
           <a:xfrm>
-            <a:off x="457200" y="1234440"/>
-            <a:ext cx="11338560" cy="4350305"/>
+            <a:off x="457200" y="1188720"/>
+            <a:ext cx="11338560" cy="3703320"/>
           </a:xfrm>
           <a:prstGeom prst="rect">
             <a:avLst/>
@@ -7141,7 +7141,7 @@
                 </a:solidFill>
                 <a:latin typeface="Calibri"/>
               </a:rPr>
-              <a:t>À esquerda: a penalidade cresce de 8,0% na base para 11,6% no topo — é o teto de vidro.</a:t>
+              <a:t>À esquerda: a penalidade cresce de 4,3% na base para 8,4% no topo — é o teto de vidro.</a:t>
             </a:r>
           </a:p>
           <a:p>
@@ -7157,7 +7157,7 @@
                 </a:solidFill>
                 <a:latin typeface="Calibri"/>
               </a:rPr>
-              <a:t>À direita: na base da distribuição, 35,1% do gap é preço diferente; no topo, 12,9% — é o piso pegajoso.</a:t>
+              <a:t>À direita: na base da distribuição, 26,5% do gap é preço diferente; no topo, 8,9% — é o piso pegajoso.</a:t>
             </a:r>
           </a:p>
         </p:txBody>
@@ -7234,7 +7234,7 @@
                 </a:solidFill>
                 <a:latin typeface="Calibri"/>
               </a:rPr>
-              <a:t>Dois retratos do mesmo fenômeno: quem está embaixo é mal pago; quem sobe encontra teto.</a:t>
+              <a:t>Duas perguntas, dois padrões: entre pares, quem sobe encontra teto; na renda do país, quem está embaixo é mal pago.</a:t>
             </a:r>
           </a:p>
         </p:txBody>
@@ -7399,7 +7399,7 @@
                 </a:solidFill>
                 <a:latin typeface="Calibri"/>
               </a:rPr>
-              <a:t>A mulher negra entra na categoria, mas não chega ao topo</a:t>
+              <a:t>A mulher negra entra pelas ocupações feminizadas, mas não chega ao comando nem ao topo</a:t>
             </a:r>
           </a:p>
         </p:txBody>
@@ -7434,7 +7434,7 @@
                 </a:solidFill>
                 <a:latin typeface="Calibri"/>
               </a:rPr>
-              <a:t>Raça e gênero não se somam: combinam-se</a:t>
+              <a:t>Raça e gênero se acumulam, sem se multiplicar</a:t>
             </a:r>
           </a:p>
         </p:txBody>
@@ -7456,7 +7456,7 @@
         <p:spPr>
           <a:xfrm>
             <a:off x="640080" y="1280160"/>
-            <a:ext cx="6035040" cy="3990707"/>
+            <a:ext cx="6035040" cy="2321169"/>
           </a:xfrm>
           <a:prstGeom prst="rect">
             <a:avLst/>
@@ -7574,7 +7574,7 @@
                 </a:solidFill>
                 <a:latin typeface="Calibri"/>
               </a:rPr>
-              <a:t>80,6%</a:t>
+              <a:t>80,7%</a:t>
             </a:r>
           </a:p>
         </p:txBody>
@@ -7694,7 +7694,7 @@
                 </a:solidFill>
                 <a:latin typeface="Calibri"/>
               </a:rPr>
-              <a:t>Penalidade além da soma raça + gênero</a:t>
+              <a:t>Raça + gênero, em log-pontos</a:t>
             </a:r>
           </a:p>
         </p:txBody>
@@ -7729,7 +7729,7 @@
                 </a:solidFill>
                 <a:latin typeface="Calibri"/>
               </a:rPr>
-              <a:t>+4,6 p.p.</a:t>
+              <a:t>0,592 &lt; 0,629</a:t>
             </a:r>
           </a:p>
         </p:txBody>
@@ -7768,7 +7768,7 @@
                 </a:solidFill>
                 <a:latin typeface="Calibri"/>
               </a:rPr>
-              <a:t>o efeito interseccional puro —</a:t>
+              <a:t>gap dela × soma dos dois eixos:</a:t>
             </a:r>
           </a:p>
           <a:p>
@@ -7784,7 +7784,7 @@
                 </a:solidFill>
                 <a:latin typeface="Calibri"/>
               </a:rPr>
-              <a:t>existe, e é menor que o dobro</a:t>
+              <a:t>acumula as duas desvantagens, sem multiplicá-las</a:t>
             </a:r>
           </a:p>
         </p:txBody>
@@ -8026,7 +8026,7 @@
                 </a:solidFill>
                 <a:latin typeface="Calibri"/>
               </a:rPr>
-              <a:t>O resultado sobrevive a tudo o que se tentou contra ele</a:t>
+              <a:t>O resultado resiste às checagens feitas</a:t>
             </a:r>
           </a:p>
         </p:txBody>
@@ -8173,7 +8173,7 @@
                 </a:solidFill>
                 <a:latin typeface="Calibri"/>
               </a:rPr>
-              <a:t>Um modelo de machine learning, que não assume relação linear, coloca a raça na 11ª posição entre 29 variáveis — mesmo com todas as informações de escolaridade e contexto.</a:t>
+              <a:t>Um modelo de machine learning, que não assume relação linear, coloca a raça na 14ª posição entre 28 variáveis — mesmo com todas as informações de escolaridade e contexto.</a:t>
             </a:r>
           </a:p>
         </p:txBody>
@@ -8285,7 +8285,7 @@
                 </a:solidFill>
                 <a:latin typeface="Calibri"/>
               </a:rPr>
-              <a:t>Um fator não medido precisaria ter força de 2,2× para anular o resultado do acesso, e seria preciso que 99,0% da estimativa do gap fosse viés.</a:t>
+              <a:t>Um fator não medido precisaria ter força de 1,5× para anular o resultado do acesso, e seria preciso que 98,4% da estimativa do gap fosse viés.</a:t>
             </a:r>
           </a:p>
         </p:txBody>
@@ -8397,7 +8397,7 @@
                 </a:solidFill>
                 <a:latin typeface="Calibri"/>
               </a:rPr>
-              <a:t>Validação cruzada de 5 partições sobre a população inteira: R² de 0,628 com variação de 0,0007 entre elas. O erro típico de previsão é de R$ 538 por mês.</a:t>
+              <a:t>Validação cruzada de 5 partições sobre a população inteira: R² de 0,644 com variação de 0,0006 entre elas. O erro típico de previsão é de R$ 664 por mês.</a:t>
             </a:r>
           </a:p>
         </p:txBody>
@@ -8509,7 +8509,7 @@
                 </a:solidFill>
                 <a:latin typeface="Calibri"/>
               </a:rPr>
-              <a:t>Retirando a renda do bairro do modelo, a contribuição da raça praticamente não muda (0,0314 contra 0,0307): o achado não é um artefato dessa variável.</a:t>
+              <a:t>Retirando a renda do bairro do modelo, a contribuição da raça praticamente não muda (0,0266 contra 0,0295): o achado não é um artefato dessa variável.</a:t>
             </a:r>
           </a:p>
         </p:txBody>
@@ -8586,7 +8586,7 @@
                 </a:solidFill>
                 <a:latin typeface="Calibri"/>
               </a:rPr>
-              <a:t>Nenhuma dessas checagens é decisiva sozinha — juntas, tornam a explicação alternativa implausível.</a:t>
+              <a:t>Nenhuma dessas checagens é decisiva sozinha — juntas, tornam a explicação alternativa menos provável.</a:t>
             </a:r>
           </a:p>
         </p:txBody>

</xml_diff>